<commit_message>
Manual PPTX: numero fantasma de seccion mas chico y tenue (se comia la diapositiva)
Co-Authored-By: Claude Opus 5 (1M context) <noreply@anthropic.com>
</commit_message>
<xml_diff>
--- a/docs/Manual-Bot-WhatsApp-Ardisa-v2.pptx
+++ b/docs/Manual-Bot-WhatsApp-Ardisa-v2.pptx
@@ -3575,8 +3575,8 @@
         </p:nvSpPr>
         <p:spPr>
           <a:xfrm>
-            <a:off x="9509760" y="-502920"/>
-            <a:ext cx="2651760" cy="2194560"/>
+            <a:off x="10561320" y="146304"/>
+            <a:ext cx="1417320" cy="960120"/>
           </a:xfrm>
           <a:prstGeom prst="rect">
             <a:avLst/>
@@ -3595,9 +3595,9 @@
               </a:spcAft>
             </a:pPr>
             <a:r>
-              <a:rPr sz="15000" b="1">
-                <a:solidFill>
-                  <a:srgbClr val="E4EBE2"/>
+              <a:rPr sz="6000" b="1">
+                <a:solidFill>
+                  <a:srgbClr val="ECF1EA"/>
                 </a:solidFill>
                 <a:latin typeface="Segoe UI"/>
               </a:rPr>
@@ -4321,8 +4321,8 @@
         </p:nvSpPr>
         <p:spPr>
           <a:xfrm>
-            <a:off x="9509760" y="-502920"/>
-            <a:ext cx="2651760" cy="2194560"/>
+            <a:off x="10561320" y="146304"/>
+            <a:ext cx="1417320" cy="960120"/>
           </a:xfrm>
           <a:prstGeom prst="rect">
             <a:avLst/>
@@ -4341,9 +4341,9 @@
               </a:spcAft>
             </a:pPr>
             <a:r>
-              <a:rPr sz="15000" b="1">
-                <a:solidFill>
-                  <a:srgbClr val="E4EBE2"/>
+              <a:rPr sz="6000" b="1">
+                <a:solidFill>
+                  <a:srgbClr val="ECF1EA"/>
                 </a:solidFill>
                 <a:latin typeface="Segoe UI"/>
               </a:rPr>
@@ -5120,8 +5120,8 @@
         </p:nvSpPr>
         <p:spPr>
           <a:xfrm>
-            <a:off x="9509760" y="-502920"/>
-            <a:ext cx="2651760" cy="2194560"/>
+            <a:off x="10561320" y="146304"/>
+            <a:ext cx="1417320" cy="960120"/>
           </a:xfrm>
           <a:prstGeom prst="rect">
             <a:avLst/>
@@ -5140,9 +5140,9 @@
               </a:spcAft>
             </a:pPr>
             <a:r>
-              <a:rPr sz="15000" b="1">
-                <a:solidFill>
-                  <a:srgbClr val="E4EBE2"/>
+              <a:rPr sz="6000" b="1">
+                <a:solidFill>
+                  <a:srgbClr val="ECF1EA"/>
                 </a:solidFill>
                 <a:latin typeface="Segoe UI"/>
               </a:rPr>
@@ -6245,8 +6245,8 @@
         </p:nvSpPr>
         <p:spPr>
           <a:xfrm>
-            <a:off x="9509760" y="-502920"/>
-            <a:ext cx="2651760" cy="2194560"/>
+            <a:off x="10561320" y="146304"/>
+            <a:ext cx="1417320" cy="960120"/>
           </a:xfrm>
           <a:prstGeom prst="rect">
             <a:avLst/>
@@ -6265,9 +6265,9 @@
               </a:spcAft>
             </a:pPr>
             <a:r>
-              <a:rPr sz="15000" b="1">
-                <a:solidFill>
-                  <a:srgbClr val="E4EBE2"/>
+              <a:rPr sz="6000" b="1">
+                <a:solidFill>
+                  <a:srgbClr val="ECF1EA"/>
                 </a:solidFill>
                 <a:latin typeface="Segoe UI"/>
               </a:rPr>
@@ -7788,8 +7788,8 @@
         </p:nvSpPr>
         <p:spPr>
           <a:xfrm>
-            <a:off x="9509760" y="-502920"/>
-            <a:ext cx="2651760" cy="2194560"/>
+            <a:off x="10561320" y="146304"/>
+            <a:ext cx="1417320" cy="960120"/>
           </a:xfrm>
           <a:prstGeom prst="rect">
             <a:avLst/>
@@ -7808,9 +7808,9 @@
               </a:spcAft>
             </a:pPr>
             <a:r>
-              <a:rPr sz="15000" b="1">
-                <a:solidFill>
-                  <a:srgbClr val="E4EBE2"/>
+              <a:rPr sz="6000" b="1">
+                <a:solidFill>
+                  <a:srgbClr val="ECF1EA"/>
                 </a:solidFill>
                 <a:latin typeface="Segoe UI"/>
               </a:rPr>
@@ -8602,8 +8602,8 @@
         </p:nvSpPr>
         <p:spPr>
           <a:xfrm>
-            <a:off x="9509760" y="-502920"/>
-            <a:ext cx="2651760" cy="2194560"/>
+            <a:off x="10561320" y="146304"/>
+            <a:ext cx="1417320" cy="960120"/>
           </a:xfrm>
           <a:prstGeom prst="rect">
             <a:avLst/>
@@ -8622,9 +8622,9 @@
               </a:spcAft>
             </a:pPr>
             <a:r>
-              <a:rPr sz="15000" b="1">
-                <a:solidFill>
-                  <a:srgbClr val="E4EBE2"/>
+              <a:rPr sz="6000" b="1">
+                <a:solidFill>
+                  <a:srgbClr val="ECF1EA"/>
                 </a:solidFill>
                 <a:latin typeface="Segoe UI"/>
               </a:rPr>
@@ -9749,8 +9749,8 @@
         </p:nvSpPr>
         <p:spPr>
           <a:xfrm>
-            <a:off x="9509760" y="-502920"/>
-            <a:ext cx="2651760" cy="2194560"/>
+            <a:off x="10561320" y="146304"/>
+            <a:ext cx="1417320" cy="960120"/>
           </a:xfrm>
           <a:prstGeom prst="rect">
             <a:avLst/>
@@ -9769,9 +9769,9 @@
               </a:spcAft>
             </a:pPr>
             <a:r>
-              <a:rPr sz="15000" b="1">
-                <a:solidFill>
-                  <a:srgbClr val="E4EBE2"/>
+              <a:rPr sz="6000" b="1">
+                <a:solidFill>
+                  <a:srgbClr val="ECF1EA"/>
                 </a:solidFill>
                 <a:latin typeface="Segoe UI"/>
               </a:rPr>
@@ -11132,8 +11132,8 @@
         </p:nvSpPr>
         <p:spPr>
           <a:xfrm>
-            <a:off x="9509760" y="-502920"/>
-            <a:ext cx="2651760" cy="2194560"/>
+            <a:off x="10561320" y="146304"/>
+            <a:ext cx="1417320" cy="960120"/>
           </a:xfrm>
           <a:prstGeom prst="rect">
             <a:avLst/>
@@ -11152,9 +11152,9 @@
               </a:spcAft>
             </a:pPr>
             <a:r>
-              <a:rPr sz="15000" b="1">
-                <a:solidFill>
-                  <a:srgbClr val="E4EBE2"/>
+              <a:rPr sz="6000" b="1">
+                <a:solidFill>
+                  <a:srgbClr val="ECF1EA"/>
                 </a:solidFill>
                 <a:latin typeface="Segoe UI"/>
               </a:rPr>
@@ -12279,8 +12279,8 @@
         </p:nvSpPr>
         <p:spPr>
           <a:xfrm>
-            <a:off x="9509760" y="-502920"/>
-            <a:ext cx="2651760" cy="2194560"/>
+            <a:off x="10561320" y="146304"/>
+            <a:ext cx="1417320" cy="960120"/>
           </a:xfrm>
           <a:prstGeom prst="rect">
             <a:avLst/>
@@ -12299,9 +12299,9 @@
               </a:spcAft>
             </a:pPr>
             <a:r>
-              <a:rPr sz="15000" b="1">
-                <a:solidFill>
-                  <a:srgbClr val="E4EBE2"/>
+              <a:rPr sz="6000" b="1">
+                <a:solidFill>
+                  <a:srgbClr val="ECF1EA"/>
                 </a:solidFill>
                 <a:latin typeface="Segoe UI"/>
               </a:rPr>
@@ -13117,8 +13117,8 @@
         </p:nvSpPr>
         <p:spPr>
           <a:xfrm>
-            <a:off x="9509760" y="-502920"/>
-            <a:ext cx="2651760" cy="2194560"/>
+            <a:off x="10561320" y="146304"/>
+            <a:ext cx="1417320" cy="960120"/>
           </a:xfrm>
           <a:prstGeom prst="rect">
             <a:avLst/>
@@ -13137,9 +13137,9 @@
               </a:spcAft>
             </a:pPr>
             <a:r>
-              <a:rPr sz="15000" b="1">
-                <a:solidFill>
-                  <a:srgbClr val="E4EBE2"/>
+              <a:rPr sz="6000" b="1">
+                <a:solidFill>
+                  <a:srgbClr val="ECF1EA"/>
                 </a:solidFill>
                 <a:latin typeface="Segoe UI"/>
               </a:rPr>
@@ -14090,8 +14090,8 @@
         </p:nvSpPr>
         <p:spPr>
           <a:xfrm>
-            <a:off x="9509760" y="-502920"/>
-            <a:ext cx="2651760" cy="2194560"/>
+            <a:off x="10561320" y="146304"/>
+            <a:ext cx="1417320" cy="960120"/>
           </a:xfrm>
           <a:prstGeom prst="rect">
             <a:avLst/>
@@ -14110,9 +14110,9 @@
               </a:spcAft>
             </a:pPr>
             <a:r>
-              <a:rPr sz="15000" b="1">
-                <a:solidFill>
-                  <a:srgbClr val="E4EBE2"/>
+              <a:rPr sz="6000" b="1">
+                <a:solidFill>
+                  <a:srgbClr val="ECF1EA"/>
                 </a:solidFill>
                 <a:latin typeface="Segoe UI"/>
               </a:rPr>

</xml_diff>